<commit_message>
link change and small polish
</commit_message>
<xml_diff>
--- a/slides/00-CourseIntroduction.pptx
+++ b/slides/00-CourseIntroduction.pptx
@@ -230,7 +230,7 @@
           <a:p>
             <a:fld id="{C5B45307-6ED4-B142-BD64-10F739779302}" type="datetimeFigureOut">
               <a:rPr lang="en-US" smtClean="0"/>
-              <a:t>8/18/26</a:t>
+              <a:t>8/25/26</a:t>
             </a:fld>
             <a:endParaRPr lang="en-US"/>
           </a:p>
@@ -733,7 +733,7 @@
           <a:noFill/>
           <a:extLst>
             <a:ext uri="{909E8E84-426E-40dd-AFC4-6F175D3DCCD1}">
-              <a14:hiddenFill xmlns:a14="http://schemas.microsoft.com/office/drawing/2010/main" xmlns="">
+              <a14:hiddenFill xmlns="" xmlns:a14="http://schemas.microsoft.com/office/drawing/2010/main">
                 <a:solidFill>
                   <a:srgbClr val="FFFFFF"/>
                 </a:solidFill>
@@ -792,7 +792,7 @@
             </a:ln>
             <a:extLst>
               <a:ext uri="{91240B29-F687-4f45-9708-019B960494DF}">
-                <a14:hiddenLine xmlns:a14="http://schemas.microsoft.com/office/drawing/2010/main" xmlns="" w="9525">
+                <a14:hiddenLine xmlns="" xmlns:a14="http://schemas.microsoft.com/office/drawing/2010/main" w="9525">
                   <a:solidFill>
                     <a:srgbClr val="000000"/>
                   </a:solidFill>
@@ -882,7 +882,7 @@
             </a:ln>
             <a:extLst>
               <a:ext uri="{91240B29-F687-4f45-9708-019B960494DF}">
-                <a14:hiddenLine xmlns:a14="http://schemas.microsoft.com/office/drawing/2010/main" xmlns="" w="9525">
+                <a14:hiddenLine xmlns="" xmlns:a14="http://schemas.microsoft.com/office/drawing/2010/main" w="9525">
                   <a:solidFill>
                     <a:srgbClr val="000000"/>
                   </a:solidFill>
@@ -972,7 +972,7 @@
             </a:ln>
             <a:extLst>
               <a:ext uri="{91240B29-F687-4f45-9708-019B960494DF}">
-                <a14:hiddenLine xmlns:a14="http://schemas.microsoft.com/office/drawing/2010/main" xmlns="" w="9525">
+                <a14:hiddenLine xmlns="" xmlns:a14="http://schemas.microsoft.com/office/drawing/2010/main" w="9525">
                   <a:solidFill>
                     <a:srgbClr val="000000"/>
                   </a:solidFill>
@@ -1006,7 +1006,7 @@
             </a:ln>
             <a:extLst>
               <a:ext uri="{91240B29-F687-4f45-9708-019B960494DF}">
-                <a14:hiddenLine xmlns:a14="http://schemas.microsoft.com/office/drawing/2010/main" xmlns="" w="9525">
+                <a14:hiddenLine xmlns="" xmlns:a14="http://schemas.microsoft.com/office/drawing/2010/main" w="9525">
                   <a:solidFill>
                     <a:srgbClr val="000000"/>
                   </a:solidFill>
@@ -1096,7 +1096,7 @@
             </a:ln>
             <a:extLst>
               <a:ext uri="{91240B29-F687-4f45-9708-019B960494DF}">
-                <a14:hiddenLine xmlns:a14="http://schemas.microsoft.com/office/drawing/2010/main" xmlns="" w="9525">
+                <a14:hiddenLine xmlns="" xmlns:a14="http://schemas.microsoft.com/office/drawing/2010/main" w="9525">
                   <a:solidFill>
                     <a:srgbClr val="000000"/>
                   </a:solidFill>
@@ -1158,7 +1158,7 @@
             </a:ln>
             <a:extLst>
               <a:ext uri="{91240B29-F687-4f45-9708-019B960494DF}">
-                <a14:hiddenLine xmlns:a14="http://schemas.microsoft.com/office/drawing/2010/main" xmlns="" w="9525">
+                <a14:hiddenLine xmlns="" xmlns:a14="http://schemas.microsoft.com/office/drawing/2010/main" w="9525">
                   <a:solidFill>
                     <a:srgbClr val="000000"/>
                   </a:solidFill>
@@ -1220,7 +1220,7 @@
             </a:ln>
             <a:extLst>
               <a:ext uri="{91240B29-F687-4f45-9708-019B960494DF}">
-                <a14:hiddenLine xmlns:a14="http://schemas.microsoft.com/office/drawing/2010/main" xmlns="" w="9525">
+                <a14:hiddenLine xmlns="" xmlns:a14="http://schemas.microsoft.com/office/drawing/2010/main" w="9525">
                   <a:solidFill>
                     <a:srgbClr val="000000"/>
                   </a:solidFill>
@@ -1310,7 +1310,7 @@
             </a:ln>
             <a:extLst>
               <a:ext uri="{91240B29-F687-4f45-9708-019B960494DF}">
-                <a14:hiddenLine xmlns:a14="http://schemas.microsoft.com/office/drawing/2010/main" xmlns="" w="9525">
+                <a14:hiddenLine xmlns="" xmlns:a14="http://schemas.microsoft.com/office/drawing/2010/main" w="9525">
                   <a:solidFill>
                     <a:srgbClr val="000000"/>
                   </a:solidFill>
@@ -1372,7 +1372,7 @@
             </a:ln>
             <a:extLst>
               <a:ext uri="{91240B29-F687-4f45-9708-019B960494DF}">
-                <a14:hiddenLine xmlns:a14="http://schemas.microsoft.com/office/drawing/2010/main" xmlns="" w="9525">
+                <a14:hiddenLine xmlns="" xmlns:a14="http://schemas.microsoft.com/office/drawing/2010/main" w="9525">
                   <a:solidFill>
                     <a:srgbClr val="000000"/>
                   </a:solidFill>
@@ -1434,7 +1434,7 @@
             </a:ln>
             <a:extLst>
               <a:ext uri="{91240B29-F687-4f45-9708-019B960494DF}">
-                <a14:hiddenLine xmlns:a14="http://schemas.microsoft.com/office/drawing/2010/main" xmlns="" w="9525">
+                <a14:hiddenLine xmlns="" xmlns:a14="http://schemas.microsoft.com/office/drawing/2010/main" w="9525">
                   <a:solidFill>
                     <a:srgbClr val="000000"/>
                   </a:solidFill>
@@ -1524,7 +1524,7 @@
             </a:ln>
             <a:extLst>
               <a:ext uri="{91240B29-F687-4f45-9708-019B960494DF}">
-                <a14:hiddenLine xmlns:a14="http://schemas.microsoft.com/office/drawing/2010/main" xmlns="" w="9525">
+                <a14:hiddenLine xmlns="" xmlns:a14="http://schemas.microsoft.com/office/drawing/2010/main" w="9525">
                   <a:solidFill>
                     <a:srgbClr val="000000"/>
                   </a:solidFill>
@@ -1614,7 +1614,7 @@
             </a:ln>
             <a:extLst>
               <a:ext uri="{91240B29-F687-4f45-9708-019B960494DF}">
-                <a14:hiddenLine xmlns:a14="http://schemas.microsoft.com/office/drawing/2010/main" xmlns="" w="9525">
+                <a14:hiddenLine xmlns="" xmlns:a14="http://schemas.microsoft.com/office/drawing/2010/main" w="9525">
                   <a:solidFill>
                     <a:srgbClr val="000000"/>
                   </a:solidFill>
@@ -1676,7 +1676,7 @@
             </a:ln>
             <a:extLst>
               <a:ext uri="{91240B29-F687-4f45-9708-019B960494DF}">
-                <a14:hiddenLine xmlns:a14="http://schemas.microsoft.com/office/drawing/2010/main" xmlns="" w="9525">
+                <a14:hiddenLine xmlns="" xmlns:a14="http://schemas.microsoft.com/office/drawing/2010/main" w="9525">
                   <a:solidFill>
                     <a:srgbClr val="000000"/>
                   </a:solidFill>
@@ -1786,7 +1786,7 @@
             </a:ln>
             <a:extLst>
               <a:ext uri="{91240B29-F687-4f45-9708-019B960494DF}">
-                <a14:hiddenLine xmlns:a14="http://schemas.microsoft.com/office/drawing/2010/main" xmlns="" w="9525">
+                <a14:hiddenLine xmlns="" xmlns:a14="http://schemas.microsoft.com/office/drawing/2010/main" w="9525">
                   <a:solidFill>
                     <a:srgbClr val="000000"/>
                   </a:solidFill>
@@ -1848,7 +1848,7 @@
             </a:ln>
             <a:extLst>
               <a:ext uri="{91240B29-F687-4f45-9708-019B960494DF}">
-                <a14:hiddenLine xmlns:a14="http://schemas.microsoft.com/office/drawing/2010/main" xmlns="" w="9525">
+                <a14:hiddenLine xmlns="" xmlns:a14="http://schemas.microsoft.com/office/drawing/2010/main" w="9525">
                   <a:solidFill>
                     <a:srgbClr val="000000"/>
                   </a:solidFill>
@@ -1938,7 +1938,7 @@
             </a:ln>
             <a:extLst>
               <a:ext uri="{91240B29-F687-4f45-9708-019B960494DF}">
-                <a14:hiddenLine xmlns:a14="http://schemas.microsoft.com/office/drawing/2010/main" xmlns="" w="9525">
+                <a14:hiddenLine xmlns="" xmlns:a14="http://schemas.microsoft.com/office/drawing/2010/main" w="9525">
                   <a:solidFill>
                     <a:srgbClr val="000000"/>
                   </a:solidFill>
@@ -2028,7 +2028,7 @@
             </a:ln>
             <a:extLst>
               <a:ext uri="{91240B29-F687-4f45-9708-019B960494DF}">
-                <a14:hiddenLine xmlns:a14="http://schemas.microsoft.com/office/drawing/2010/main" xmlns="" w="9525">
+                <a14:hiddenLine xmlns="" xmlns:a14="http://schemas.microsoft.com/office/drawing/2010/main" w="9525">
                   <a:solidFill>
                     <a:srgbClr val="000000"/>
                   </a:solidFill>
@@ -2090,7 +2090,7 @@
             </a:ln>
             <a:extLst>
               <a:ext uri="{91240B29-F687-4f45-9708-019B960494DF}">
-                <a14:hiddenLine xmlns:a14="http://schemas.microsoft.com/office/drawing/2010/main" xmlns="" w="9525">
+                <a14:hiddenLine xmlns="" xmlns:a14="http://schemas.microsoft.com/office/drawing/2010/main" w="9525">
                   <a:solidFill>
                     <a:srgbClr val="000000"/>
                   </a:solidFill>
@@ -2180,7 +2180,7 @@
             </a:ln>
             <a:extLst>
               <a:ext uri="{91240B29-F687-4f45-9708-019B960494DF}">
-                <a14:hiddenLine xmlns:a14="http://schemas.microsoft.com/office/drawing/2010/main" xmlns="" w="9525">
+                <a14:hiddenLine xmlns="" xmlns:a14="http://schemas.microsoft.com/office/drawing/2010/main" w="9525">
                   <a:solidFill>
                     <a:srgbClr val="000000"/>
                   </a:solidFill>
@@ -2270,7 +2270,7 @@
             </a:ln>
             <a:extLst>
               <a:ext uri="{91240B29-F687-4f45-9708-019B960494DF}">
-                <a14:hiddenLine xmlns:a14="http://schemas.microsoft.com/office/drawing/2010/main" xmlns="" w="9525">
+                <a14:hiddenLine xmlns="" xmlns:a14="http://schemas.microsoft.com/office/drawing/2010/main" w="9525">
                   <a:solidFill>
                     <a:srgbClr val="000000"/>
                   </a:solidFill>
@@ -2326,7 +2326,7 @@
             </a:ln>
             <a:extLst>
               <a:ext uri="{91240B29-F687-4f45-9708-019B960494DF}">
-                <a14:hiddenLine xmlns:a14="http://schemas.microsoft.com/office/drawing/2010/main" xmlns="" w="9525">
+                <a14:hiddenLine xmlns="" xmlns:a14="http://schemas.microsoft.com/office/drawing/2010/main" w="9525">
                   <a:solidFill>
                     <a:srgbClr val="000000"/>
                   </a:solidFill>
@@ -2416,7 +2416,7 @@
             </a:ln>
             <a:extLst>
               <a:ext uri="{91240B29-F687-4f45-9708-019B960494DF}">
-                <a14:hiddenLine xmlns:a14="http://schemas.microsoft.com/office/drawing/2010/main" xmlns="" w="9525">
+                <a14:hiddenLine xmlns="" xmlns:a14="http://schemas.microsoft.com/office/drawing/2010/main" w="9525">
                   <a:solidFill>
                     <a:srgbClr val="000000"/>
                   </a:solidFill>
@@ -2472,7 +2472,7 @@
             </a:ln>
             <a:extLst>
               <a:ext uri="{91240B29-F687-4f45-9708-019B960494DF}">
-                <a14:hiddenLine xmlns:a14="http://schemas.microsoft.com/office/drawing/2010/main" xmlns="" w="9525">
+                <a14:hiddenLine xmlns="" xmlns:a14="http://schemas.microsoft.com/office/drawing/2010/main" w="9525">
                   <a:solidFill>
                     <a:srgbClr val="000000"/>
                   </a:solidFill>
@@ -2562,7 +2562,7 @@
             </a:ln>
             <a:extLst>
               <a:ext uri="{91240B29-F687-4f45-9708-019B960494DF}">
-                <a14:hiddenLine xmlns:a14="http://schemas.microsoft.com/office/drawing/2010/main" xmlns="" w="9525">
+                <a14:hiddenLine xmlns="" xmlns:a14="http://schemas.microsoft.com/office/drawing/2010/main" w="9525">
                   <a:solidFill>
                     <a:srgbClr val="000000"/>
                   </a:solidFill>
@@ -2630,7 +2630,7 @@
             </a:ln>
             <a:extLst>
               <a:ext uri="{91240B29-F687-4f45-9708-019B960494DF}">
-                <a14:hiddenLine xmlns:a14="http://schemas.microsoft.com/office/drawing/2010/main" xmlns="" w="9525">
+                <a14:hiddenLine xmlns="" xmlns:a14="http://schemas.microsoft.com/office/drawing/2010/main" w="9525">
                   <a:solidFill>
                     <a:srgbClr val="000000"/>
                   </a:solidFill>
@@ -2720,7 +2720,7 @@
             </a:ln>
             <a:extLst>
               <a:ext uri="{91240B29-F687-4f45-9708-019B960494DF}">
-                <a14:hiddenLine xmlns:a14="http://schemas.microsoft.com/office/drawing/2010/main" xmlns="" w="9525">
+                <a14:hiddenLine xmlns="" xmlns:a14="http://schemas.microsoft.com/office/drawing/2010/main" w="9525">
                   <a:solidFill>
                     <a:srgbClr val="000000"/>
                   </a:solidFill>
@@ -2788,7 +2788,7 @@
             </a:ln>
             <a:extLst>
               <a:ext uri="{91240B29-F687-4f45-9708-019B960494DF}">
-                <a14:hiddenLine xmlns:a14="http://schemas.microsoft.com/office/drawing/2010/main" xmlns="" w="9525">
+                <a14:hiddenLine xmlns="" xmlns:a14="http://schemas.microsoft.com/office/drawing/2010/main" w="9525">
                   <a:solidFill>
                     <a:srgbClr val="000000"/>
                   </a:solidFill>
@@ -2878,7 +2878,7 @@
             </a:ln>
             <a:extLst>
               <a:ext uri="{91240B29-F687-4f45-9708-019B960494DF}">
-                <a14:hiddenLine xmlns:a14="http://schemas.microsoft.com/office/drawing/2010/main" xmlns="" w="9525">
+                <a14:hiddenLine xmlns="" xmlns:a14="http://schemas.microsoft.com/office/drawing/2010/main" w="9525">
                   <a:solidFill>
                     <a:srgbClr val="000000"/>
                   </a:solidFill>
@@ -2912,7 +2912,7 @@
             </a:ln>
             <a:extLst>
               <a:ext uri="{91240B29-F687-4f45-9708-019B960494DF}">
-                <a14:hiddenLine xmlns:a14="http://schemas.microsoft.com/office/drawing/2010/main" xmlns="" w="9525">
+                <a14:hiddenLine xmlns="" xmlns:a14="http://schemas.microsoft.com/office/drawing/2010/main" w="9525">
                   <a:solidFill>
                     <a:srgbClr val="000000"/>
                   </a:solidFill>
@@ -3002,7 +3002,7 @@
             </a:ln>
             <a:extLst>
               <a:ext uri="{91240B29-F687-4f45-9708-019B960494DF}">
-                <a14:hiddenLine xmlns:a14="http://schemas.microsoft.com/office/drawing/2010/main" xmlns="" w="9525">
+                <a14:hiddenLine xmlns="" xmlns:a14="http://schemas.microsoft.com/office/drawing/2010/main" w="9525">
                   <a:solidFill>
                     <a:srgbClr val="000000"/>
                   </a:solidFill>
@@ -3064,7 +3064,7 @@
             </a:ln>
             <a:extLst>
               <a:ext uri="{91240B29-F687-4f45-9708-019B960494DF}">
-                <a14:hiddenLine xmlns:a14="http://schemas.microsoft.com/office/drawing/2010/main" xmlns="" w="9525">
+                <a14:hiddenLine xmlns="" xmlns:a14="http://schemas.microsoft.com/office/drawing/2010/main" w="9525">
                   <a:solidFill>
                     <a:srgbClr val="000000"/>
                   </a:solidFill>
@@ -3126,7 +3126,7 @@
             </a:ln>
             <a:extLst>
               <a:ext uri="{91240B29-F687-4f45-9708-019B960494DF}">
-                <a14:hiddenLine xmlns:a14="http://schemas.microsoft.com/office/drawing/2010/main" xmlns="" w="9525">
+                <a14:hiddenLine xmlns="" xmlns:a14="http://schemas.microsoft.com/office/drawing/2010/main" w="9525">
                   <a:solidFill>
                     <a:srgbClr val="000000"/>
                   </a:solidFill>
@@ -3216,7 +3216,7 @@
             </a:ln>
             <a:extLst>
               <a:ext uri="{91240B29-F687-4f45-9708-019B960494DF}">
-                <a14:hiddenLine xmlns:a14="http://schemas.microsoft.com/office/drawing/2010/main" xmlns="" w="9525">
+                <a14:hiddenLine xmlns="" xmlns:a14="http://schemas.microsoft.com/office/drawing/2010/main" w="9525">
                   <a:solidFill>
                     <a:srgbClr val="000000"/>
                   </a:solidFill>
@@ -3284,7 +3284,7 @@
             </a:ln>
             <a:extLst>
               <a:ext uri="{91240B29-F687-4f45-9708-019B960494DF}">
-                <a14:hiddenLine xmlns:a14="http://schemas.microsoft.com/office/drawing/2010/main" xmlns="" w="9525">
+                <a14:hiddenLine xmlns="" xmlns:a14="http://schemas.microsoft.com/office/drawing/2010/main" w="9525">
                   <a:solidFill>
                     <a:srgbClr val="000000"/>
                   </a:solidFill>
@@ -3346,7 +3346,7 @@
             </a:ln>
             <a:extLst>
               <a:ext uri="{91240B29-F687-4f45-9708-019B960494DF}">
-                <a14:hiddenLine xmlns:a14="http://schemas.microsoft.com/office/drawing/2010/main" xmlns="" w="9525">
+                <a14:hiddenLine xmlns="" xmlns:a14="http://schemas.microsoft.com/office/drawing/2010/main" w="9525">
                   <a:solidFill>
                     <a:srgbClr val="000000"/>
                   </a:solidFill>
@@ -3436,7 +3436,7 @@
             </a:ln>
             <a:extLst>
               <a:ext uri="{91240B29-F687-4f45-9708-019B960494DF}">
-                <a14:hiddenLine xmlns:a14="http://schemas.microsoft.com/office/drawing/2010/main" xmlns="" w="9525">
+                <a14:hiddenLine xmlns="" xmlns:a14="http://schemas.microsoft.com/office/drawing/2010/main" w="9525">
                   <a:solidFill>
                     <a:srgbClr val="000000"/>
                   </a:solidFill>
@@ -3498,7 +3498,7 @@
             </a:ln>
             <a:extLst>
               <a:ext uri="{91240B29-F687-4f45-9708-019B960494DF}">
-                <a14:hiddenLine xmlns:a14="http://schemas.microsoft.com/office/drawing/2010/main" xmlns="" w="9525">
+                <a14:hiddenLine xmlns="" xmlns:a14="http://schemas.microsoft.com/office/drawing/2010/main" w="9525">
                   <a:solidFill>
                     <a:srgbClr val="000000"/>
                   </a:solidFill>
@@ -3588,7 +3588,7 @@
             </a:ln>
             <a:extLst>
               <a:ext uri="{91240B29-F687-4f45-9708-019B960494DF}">
-                <a14:hiddenLine xmlns:a14="http://schemas.microsoft.com/office/drawing/2010/main" xmlns="" w="9525">
+                <a14:hiddenLine xmlns="" xmlns:a14="http://schemas.microsoft.com/office/drawing/2010/main" w="9525">
                   <a:solidFill>
                     <a:srgbClr val="000000"/>
                   </a:solidFill>
@@ -3650,7 +3650,7 @@
             </a:ln>
             <a:extLst>
               <a:ext uri="{91240B29-F687-4f45-9708-019B960494DF}">
-                <a14:hiddenLine xmlns:a14="http://schemas.microsoft.com/office/drawing/2010/main" xmlns="" w="9525">
+                <a14:hiddenLine xmlns="" xmlns:a14="http://schemas.microsoft.com/office/drawing/2010/main" w="9525">
                   <a:solidFill>
                     <a:srgbClr val="000000"/>
                   </a:solidFill>
@@ -3740,7 +3740,7 @@
             </a:ln>
             <a:extLst>
               <a:ext uri="{91240B29-F687-4f45-9708-019B960494DF}">
-                <a14:hiddenLine xmlns:a14="http://schemas.microsoft.com/office/drawing/2010/main" xmlns="" w="9525">
+                <a14:hiddenLine xmlns="" xmlns:a14="http://schemas.microsoft.com/office/drawing/2010/main" w="9525">
                   <a:solidFill>
                     <a:srgbClr val="000000"/>
                   </a:solidFill>
@@ -3774,7 +3774,7 @@
             </a:ln>
             <a:extLst>
               <a:ext uri="{91240B29-F687-4f45-9708-019B960494DF}">
-                <a14:hiddenLine xmlns:a14="http://schemas.microsoft.com/office/drawing/2010/main" xmlns="" w="9525">
+                <a14:hiddenLine xmlns="" xmlns:a14="http://schemas.microsoft.com/office/drawing/2010/main" w="9525">
                   <a:solidFill>
                     <a:srgbClr val="000000"/>
                   </a:solidFill>
@@ -3839,7 +3839,7 @@
             </a:ln>
             <a:extLst>
               <a:ext uri="{91240B29-F687-4f45-9708-019B960494DF}">
-                <a14:hiddenLine xmlns:a14="http://schemas.microsoft.com/office/drawing/2010/main" xmlns="" w="9525">
+                <a14:hiddenLine xmlns="" xmlns:a14="http://schemas.microsoft.com/office/drawing/2010/main" w="9525">
                   <a:solidFill>
                     <a:srgbClr val="000000"/>
                   </a:solidFill>
@@ -3929,7 +3929,7 @@
             </a:ln>
             <a:extLst>
               <a:ext uri="{91240B29-F687-4f45-9708-019B960494DF}">
-                <a14:hiddenLine xmlns:a14="http://schemas.microsoft.com/office/drawing/2010/main" xmlns="" w="9525">
+                <a14:hiddenLine xmlns="" xmlns:a14="http://schemas.microsoft.com/office/drawing/2010/main" w="9525">
                   <a:solidFill>
                     <a:srgbClr val="000000"/>
                   </a:solidFill>
@@ -3991,7 +3991,7 @@
             </a:ln>
             <a:extLst>
               <a:ext uri="{91240B29-F687-4f45-9708-019B960494DF}">
-                <a14:hiddenLine xmlns:a14="http://schemas.microsoft.com/office/drawing/2010/main" xmlns="" w="9525">
+                <a14:hiddenLine xmlns="" xmlns:a14="http://schemas.microsoft.com/office/drawing/2010/main" w="9525">
                   <a:solidFill>
                     <a:srgbClr val="000000"/>
                   </a:solidFill>
@@ -4081,7 +4081,7 @@
             </a:ln>
             <a:extLst>
               <a:ext uri="{91240B29-F687-4f45-9708-019B960494DF}">
-                <a14:hiddenLine xmlns:a14="http://schemas.microsoft.com/office/drawing/2010/main" xmlns="" w="9525">
+                <a14:hiddenLine xmlns="" xmlns:a14="http://schemas.microsoft.com/office/drawing/2010/main" w="9525">
                   <a:solidFill>
                     <a:srgbClr val="000000"/>
                   </a:solidFill>
@@ -4171,7 +4171,7 @@
             </a:ln>
             <a:extLst>
               <a:ext uri="{91240B29-F687-4f45-9708-019B960494DF}">
-                <a14:hiddenLine xmlns:a14="http://schemas.microsoft.com/office/drawing/2010/main" xmlns="" w="9525">
+                <a14:hiddenLine xmlns="" xmlns:a14="http://schemas.microsoft.com/office/drawing/2010/main" w="9525">
                   <a:solidFill>
                     <a:srgbClr val="000000"/>
                   </a:solidFill>
@@ -4236,7 +4236,7 @@
             </a:ln>
             <a:extLst>
               <a:ext uri="{91240B29-F687-4f45-9708-019B960494DF}">
-                <a14:hiddenLine xmlns:a14="http://schemas.microsoft.com/office/drawing/2010/main" xmlns="" w="9525">
+                <a14:hiddenLine xmlns="" xmlns:a14="http://schemas.microsoft.com/office/drawing/2010/main" w="9525">
                   <a:solidFill>
                     <a:srgbClr val="000000"/>
                   </a:solidFill>
@@ -4298,7 +4298,7 @@
             </a:ln>
             <a:extLst>
               <a:ext uri="{91240B29-F687-4f45-9708-019B960494DF}">
-                <a14:hiddenLine xmlns:a14="http://schemas.microsoft.com/office/drawing/2010/main" xmlns="" w="9525">
+                <a14:hiddenLine xmlns="" xmlns:a14="http://schemas.microsoft.com/office/drawing/2010/main" w="9525">
                   <a:solidFill>
                     <a:srgbClr val="000000"/>
                   </a:solidFill>
@@ -4388,7 +4388,7 @@
             </a:ln>
             <a:extLst>
               <a:ext uri="{91240B29-F687-4f45-9708-019B960494DF}">
-                <a14:hiddenLine xmlns:a14="http://schemas.microsoft.com/office/drawing/2010/main" xmlns="" w="9525">
+                <a14:hiddenLine xmlns="" xmlns:a14="http://schemas.microsoft.com/office/drawing/2010/main" w="9525">
                   <a:solidFill>
                     <a:srgbClr val="000000"/>
                   </a:solidFill>
@@ -4478,7 +4478,7 @@
             </a:ln>
             <a:extLst>
               <a:ext uri="{91240B29-F687-4f45-9708-019B960494DF}">
-                <a14:hiddenLine xmlns:a14="http://schemas.microsoft.com/office/drawing/2010/main" xmlns="" w="9525">
+                <a14:hiddenLine xmlns="" xmlns:a14="http://schemas.microsoft.com/office/drawing/2010/main" w="9525">
                   <a:solidFill>
                     <a:srgbClr val="000000"/>
                   </a:solidFill>
@@ -4540,7 +4540,7 @@
             </a:ln>
             <a:extLst>
               <a:ext uri="{91240B29-F687-4f45-9708-019B960494DF}">
-                <a14:hiddenLine xmlns:a14="http://schemas.microsoft.com/office/drawing/2010/main" xmlns="" w="9525">
+                <a14:hiddenLine xmlns="" xmlns:a14="http://schemas.microsoft.com/office/drawing/2010/main" w="9525">
                   <a:solidFill>
                     <a:srgbClr val="000000"/>
                   </a:solidFill>
@@ -4660,7 +4660,7 @@
             </a:ln>
             <a:extLst>
               <a:ext uri="{91240B29-F687-4f45-9708-019B960494DF}">
-                <a14:hiddenLine xmlns:a14="http://schemas.microsoft.com/office/drawing/2010/main" xmlns="" w="9525">
+                <a14:hiddenLine xmlns="" xmlns:a14="http://schemas.microsoft.com/office/drawing/2010/main" w="9525">
                   <a:solidFill>
                     <a:srgbClr val="000000"/>
                   </a:solidFill>
@@ -4728,7 +4728,7 @@
             </a:ln>
             <a:extLst>
               <a:ext uri="{91240B29-F687-4f45-9708-019B960494DF}">
-                <a14:hiddenLine xmlns:a14="http://schemas.microsoft.com/office/drawing/2010/main" xmlns="" w="9525">
+                <a14:hiddenLine xmlns="" xmlns:a14="http://schemas.microsoft.com/office/drawing/2010/main" w="9525">
                   <a:solidFill>
                     <a:srgbClr val="000000"/>
                   </a:solidFill>
@@ -4818,7 +4818,7 @@
             </a:ln>
             <a:extLst>
               <a:ext uri="{91240B29-F687-4f45-9708-019B960494DF}">
-                <a14:hiddenLine xmlns:a14="http://schemas.microsoft.com/office/drawing/2010/main" xmlns="" w="9525">
+                <a14:hiddenLine xmlns="" xmlns:a14="http://schemas.microsoft.com/office/drawing/2010/main" w="9525">
                   <a:solidFill>
                     <a:srgbClr val="000000"/>
                   </a:solidFill>
@@ -4958,7 +4958,7 @@
           <a:p>
             <a:fld id="{402D7A8C-E8C9-C044-B17F-4F3BDC02CA13}" type="datetime1">
               <a:rPr lang="en-US" smtClean="0"/>
-              <a:t>8/18/26</a:t>
+              <a:t>8/25/26</a:t>
             </a:fld>
             <a:endParaRPr lang="en-US"/>
           </a:p>
@@ -5225,7 +5225,7 @@
           <a:p>
             <a:fld id="{37F8A4E9-907E-024F-942D-1027DBDB6B95}" type="datetime1">
               <a:rPr lang="en-US" smtClean="0"/>
-              <a:t>8/18/26</a:t>
+              <a:t>8/25/26</a:t>
             </a:fld>
             <a:endParaRPr lang="en-US"/>
           </a:p>
@@ -5421,7 +5421,7 @@
           <a:p>
             <a:fld id="{0FE75626-F07C-1141-9EC1-D81C02E85261}" type="datetime1">
               <a:rPr lang="en-US" smtClean="0"/>
-              <a:t>8/18/26</a:t>
+              <a:t>8/25/26</a:t>
             </a:fld>
             <a:endParaRPr lang="en-US"/>
           </a:p>
@@ -5684,7 +5684,7 @@
           <a:p>
             <a:fld id="{A542032B-A565-A745-AD03-A3A1AE898D44}" type="datetime1">
               <a:rPr lang="en-US" smtClean="0"/>
-              <a:t>8/18/26</a:t>
+              <a:t>8/25/26</a:t>
             </a:fld>
             <a:endParaRPr lang="en-US"/>
           </a:p>
@@ -6118,7 +6118,7 @@
           <a:p>
             <a:fld id="{D07DFA05-D8BC-F743-AAC8-830078F9EC2E}" type="datetime1">
               <a:rPr lang="en-US" smtClean="0"/>
-              <a:t>8/18/26</a:t>
+              <a:t>8/25/26</a:t>
             </a:fld>
             <a:endParaRPr lang="en-US"/>
           </a:p>
@@ -6664,7 +6664,7 @@
           <a:p>
             <a:fld id="{A30ACE03-F6AA-B648-AEDA-6D288BF5F57D}" type="datetime1">
               <a:rPr lang="en-US" smtClean="0"/>
-              <a:t>8/18/26</a:t>
+              <a:t>8/25/26</a:t>
             </a:fld>
             <a:endParaRPr lang="en-US"/>
           </a:p>
@@ -7384,7 +7384,7 @@
           <a:p>
             <a:fld id="{00CC296A-FFCD-5143-BB88-7498A31860D8}" type="datetime1">
               <a:rPr lang="en-US" smtClean="0"/>
-              <a:t>8/18/26</a:t>
+              <a:t>8/25/26</a:t>
             </a:fld>
             <a:endParaRPr lang="en-US"/>
           </a:p>
@@ -7554,7 +7554,7 @@
           <a:p>
             <a:fld id="{C6A5FF73-2E33-5542-B000-2DC2E7840EBF}" type="datetime1">
               <a:rPr lang="en-US" smtClean="0"/>
-              <a:t>8/18/26</a:t>
+              <a:t>8/25/26</a:t>
             </a:fld>
             <a:endParaRPr lang="en-US"/>
           </a:p>
@@ -7734,7 +7734,7 @@
           <a:p>
             <a:fld id="{02F42606-263B-9C4F-8747-C46201865648}" type="datetime1">
               <a:rPr lang="en-US" smtClean="0"/>
-              <a:t>8/18/26</a:t>
+              <a:t>8/25/26</a:t>
             </a:fld>
             <a:endParaRPr lang="en-US"/>
           </a:p>
@@ -7904,7 +7904,7 @@
           <a:p>
             <a:fld id="{5F8D537B-242B-6E4B-B3AA-5700AD130DAB}" type="datetime1">
               <a:rPr lang="en-US" smtClean="0"/>
-              <a:t>8/18/26</a:t>
+              <a:t>8/25/26</a:t>
             </a:fld>
             <a:endParaRPr lang="en-US"/>
           </a:p>
@@ -8154,7 +8154,7 @@
           <a:p>
             <a:fld id="{7BE0DB53-1439-2E4C-8FEF-8A4982596F3C}" type="datetime1">
               <a:rPr lang="en-US" smtClean="0"/>
-              <a:t>8/18/26</a:t>
+              <a:t>8/25/26</a:t>
             </a:fld>
             <a:endParaRPr lang="en-US"/>
           </a:p>
@@ -8386,7 +8386,7 @@
           <a:p>
             <a:fld id="{DC68B4C4-E214-B54E-A5C2-DF036DC63B34}" type="datetime1">
               <a:rPr lang="en-US" smtClean="0"/>
-              <a:t>8/18/26</a:t>
+              <a:t>8/25/26</a:t>
             </a:fld>
             <a:endParaRPr lang="en-US"/>
           </a:p>
@@ -8772,7 +8772,7 @@
           <a:p>
             <a:fld id="{7FAC456D-E6B2-0642-9BEB-83D0B9BAC47F}" type="datetime1">
               <a:rPr lang="en-US" smtClean="0"/>
-              <a:t>8/18/26</a:t>
+              <a:t>8/25/26</a:t>
             </a:fld>
             <a:endParaRPr lang="en-US"/>
           </a:p>
@@ -8895,7 +8895,7 @@
           <a:p>
             <a:fld id="{16AA1968-45EA-A240-A17F-44B2A8A0BB1D}" type="datetime1">
               <a:rPr lang="en-US" smtClean="0"/>
-              <a:t>8/18/26</a:t>
+              <a:t>8/25/26</a:t>
             </a:fld>
             <a:endParaRPr lang="en-US"/>
           </a:p>
@@ -8990,7 +8990,7 @@
           <a:p>
             <a:fld id="{26CFB313-9C91-AB4A-9BD3-BE60645D454E}" type="datetime1">
               <a:rPr lang="en-US" smtClean="0"/>
-              <a:t>8/18/26</a:t>
+              <a:t>8/25/26</a:t>
             </a:fld>
             <a:endParaRPr lang="en-US"/>
           </a:p>
@@ -9239,7 +9239,7 @@
           <a:p>
             <a:fld id="{400DE57A-C1B2-FD48-B4C3-5BEA75776498}" type="datetime1">
               <a:rPr lang="en-US" smtClean="0"/>
-              <a:t>8/18/26</a:t>
+              <a:t>8/25/26</a:t>
             </a:fld>
             <a:endParaRPr lang="en-US"/>
           </a:p>
@@ -9524,7 +9524,7 @@
           <a:p>
             <a:fld id="{A982DE63-F783-CF4C-A886-D3D65D6D3AA3}" type="datetime1">
               <a:rPr lang="en-US" smtClean="0"/>
-              <a:t>8/18/26</a:t>
+              <a:t>8/25/26</a:t>
             </a:fld>
             <a:endParaRPr lang="en-US"/>
           </a:p>
@@ -9647,7 +9647,7 @@
           <a:noFill/>
           <a:extLst>
             <a:ext uri="{909E8E84-426E-40dd-AFC4-6F175D3DCCD1}">
-              <a14:hiddenFill xmlns:a14="http://schemas.microsoft.com/office/drawing/2010/main" xmlns="">
+              <a14:hiddenFill xmlns="" xmlns:a14="http://schemas.microsoft.com/office/drawing/2010/main">
                 <a:solidFill>
                   <a:srgbClr val="FFFFFF"/>
                 </a:solidFill>
@@ -9721,7 +9721,7 @@
               </a:ln>
               <a:extLst>
                 <a:ext uri="{91240B29-F687-4f45-9708-019B960494DF}">
-                  <a14:hiddenLine xmlns:a14="http://schemas.microsoft.com/office/drawing/2010/main" xmlns="" w="9525">
+                  <a14:hiddenLine xmlns="" xmlns:a14="http://schemas.microsoft.com/office/drawing/2010/main" w="9525">
                     <a:solidFill>
                       <a:srgbClr val="000000"/>
                     </a:solidFill>
@@ -9811,7 +9811,7 @@
               </a:ln>
               <a:extLst>
                 <a:ext uri="{91240B29-F687-4f45-9708-019B960494DF}">
-                  <a14:hiddenLine xmlns:a14="http://schemas.microsoft.com/office/drawing/2010/main" xmlns="" w="9525">
+                  <a14:hiddenLine xmlns="" xmlns:a14="http://schemas.microsoft.com/office/drawing/2010/main" w="9525">
                     <a:solidFill>
                       <a:srgbClr val="000000"/>
                     </a:solidFill>
@@ -9901,7 +9901,7 @@
               </a:ln>
               <a:extLst>
                 <a:ext uri="{91240B29-F687-4f45-9708-019B960494DF}">
-                  <a14:hiddenLine xmlns:a14="http://schemas.microsoft.com/office/drawing/2010/main" xmlns="" w="9525">
+                  <a14:hiddenLine xmlns="" xmlns:a14="http://schemas.microsoft.com/office/drawing/2010/main" w="9525">
                     <a:solidFill>
                       <a:srgbClr val="000000"/>
                     </a:solidFill>
@@ -9963,7 +9963,7 @@
               </a:ln>
               <a:extLst>
                 <a:ext uri="{91240B29-F687-4f45-9708-019B960494DF}">
-                  <a14:hiddenLine xmlns:a14="http://schemas.microsoft.com/office/drawing/2010/main" xmlns="" w="9525">
+                  <a14:hiddenLine xmlns="" xmlns:a14="http://schemas.microsoft.com/office/drawing/2010/main" w="9525">
                     <a:solidFill>
                       <a:srgbClr val="000000"/>
                     </a:solidFill>
@@ -10053,7 +10053,7 @@
               </a:ln>
               <a:extLst>
                 <a:ext uri="{91240B29-F687-4f45-9708-019B960494DF}">
-                  <a14:hiddenLine xmlns:a14="http://schemas.microsoft.com/office/drawing/2010/main" xmlns="" w="9525">
+                  <a14:hiddenLine xmlns="" xmlns:a14="http://schemas.microsoft.com/office/drawing/2010/main" w="9525">
                     <a:solidFill>
                       <a:srgbClr val="000000"/>
                     </a:solidFill>
@@ -10115,7 +10115,7 @@
               </a:ln>
               <a:extLst>
                 <a:ext uri="{91240B29-F687-4f45-9708-019B960494DF}">
-                  <a14:hiddenLine xmlns:a14="http://schemas.microsoft.com/office/drawing/2010/main" xmlns="" w="9525">
+                  <a14:hiddenLine xmlns="" xmlns:a14="http://schemas.microsoft.com/office/drawing/2010/main" w="9525">
                     <a:solidFill>
                       <a:srgbClr val="000000"/>
                     </a:solidFill>
@@ -10177,7 +10177,7 @@
               </a:ln>
               <a:extLst>
                 <a:ext uri="{91240B29-F687-4f45-9708-019B960494DF}">
-                  <a14:hiddenLine xmlns:a14="http://schemas.microsoft.com/office/drawing/2010/main" xmlns="" w="9525">
+                  <a14:hiddenLine xmlns="" xmlns:a14="http://schemas.microsoft.com/office/drawing/2010/main" w="9525">
                     <a:solidFill>
                       <a:srgbClr val="000000"/>
                     </a:solidFill>
@@ -10267,7 +10267,7 @@
               </a:ln>
               <a:extLst>
                 <a:ext uri="{91240B29-F687-4f45-9708-019B960494DF}">
-                  <a14:hiddenLine xmlns:a14="http://schemas.microsoft.com/office/drawing/2010/main" xmlns="" w="9525">
+                  <a14:hiddenLine xmlns="" xmlns:a14="http://schemas.microsoft.com/office/drawing/2010/main" w="9525">
                     <a:solidFill>
                       <a:srgbClr val="000000"/>
                     </a:solidFill>
@@ -10357,7 +10357,7 @@
               </a:ln>
               <a:extLst>
                 <a:ext uri="{91240B29-F687-4f45-9708-019B960494DF}">
-                  <a14:hiddenLine xmlns:a14="http://schemas.microsoft.com/office/drawing/2010/main" xmlns="" w="9525">
+                  <a14:hiddenLine xmlns="" xmlns:a14="http://schemas.microsoft.com/office/drawing/2010/main" w="9525">
                     <a:solidFill>
                       <a:srgbClr val="000000"/>
                     </a:solidFill>
@@ -10419,7 +10419,7 @@
               </a:ln>
               <a:extLst>
                 <a:ext uri="{91240B29-F687-4f45-9708-019B960494DF}">
-                  <a14:hiddenLine xmlns:a14="http://schemas.microsoft.com/office/drawing/2010/main" xmlns="" w="9525">
+                  <a14:hiddenLine xmlns="" xmlns:a14="http://schemas.microsoft.com/office/drawing/2010/main" w="9525">
                     <a:solidFill>
                       <a:srgbClr val="000000"/>
                     </a:solidFill>
@@ -10529,7 +10529,7 @@
               </a:ln>
               <a:extLst>
                 <a:ext uri="{91240B29-F687-4f45-9708-019B960494DF}">
-                  <a14:hiddenLine xmlns:a14="http://schemas.microsoft.com/office/drawing/2010/main" xmlns="" w="9525">
+                  <a14:hiddenLine xmlns="" xmlns:a14="http://schemas.microsoft.com/office/drawing/2010/main" w="9525">
                     <a:solidFill>
                       <a:srgbClr val="000000"/>
                     </a:solidFill>
@@ -10613,7 +10613,7 @@
               </a:ln>
               <a:extLst>
                 <a:ext uri="{91240B29-F687-4f45-9708-019B960494DF}">
-                  <a14:hiddenLine xmlns:a14="http://schemas.microsoft.com/office/drawing/2010/main" xmlns="" w="9525">
+                  <a14:hiddenLine xmlns="" xmlns:a14="http://schemas.microsoft.com/office/drawing/2010/main" w="9525">
                     <a:solidFill>
                       <a:srgbClr val="000000"/>
                     </a:solidFill>
@@ -10675,7 +10675,7 @@
               </a:ln>
               <a:extLst>
                 <a:ext uri="{91240B29-F687-4f45-9708-019B960494DF}">
-                  <a14:hiddenLine xmlns:a14="http://schemas.microsoft.com/office/drawing/2010/main" xmlns="" w="9525">
+                  <a14:hiddenLine xmlns="" xmlns:a14="http://schemas.microsoft.com/office/drawing/2010/main" w="9525">
                     <a:solidFill>
                       <a:srgbClr val="000000"/>
                     </a:solidFill>
@@ -10737,7 +10737,7 @@
               </a:ln>
               <a:extLst>
                 <a:ext uri="{91240B29-F687-4f45-9708-019B960494DF}">
-                  <a14:hiddenLine xmlns:a14="http://schemas.microsoft.com/office/drawing/2010/main" xmlns="" w="9525">
+                  <a14:hiddenLine xmlns="" xmlns:a14="http://schemas.microsoft.com/office/drawing/2010/main" w="9525">
                     <a:solidFill>
                       <a:srgbClr val="000000"/>
                     </a:solidFill>
@@ -10827,7 +10827,7 @@
               </a:ln>
               <a:extLst>
                 <a:ext uri="{91240B29-F687-4f45-9708-019B960494DF}">
-                  <a14:hiddenLine xmlns:a14="http://schemas.microsoft.com/office/drawing/2010/main" xmlns="" w="9525">
+                  <a14:hiddenLine xmlns="" xmlns:a14="http://schemas.microsoft.com/office/drawing/2010/main" w="9525">
                     <a:solidFill>
                       <a:srgbClr val="000000"/>
                     </a:solidFill>
@@ -10861,7 +10861,7 @@
               </a:ln>
               <a:extLst>
                 <a:ext uri="{91240B29-F687-4f45-9708-019B960494DF}">
-                  <a14:hiddenLine xmlns:a14="http://schemas.microsoft.com/office/drawing/2010/main" xmlns="" w="9525">
+                  <a14:hiddenLine xmlns="" xmlns:a14="http://schemas.microsoft.com/office/drawing/2010/main" w="9525">
                     <a:solidFill>
                       <a:srgbClr val="000000"/>
                     </a:solidFill>
@@ -10926,7 +10926,7 @@
               </a:ln>
               <a:extLst>
                 <a:ext uri="{91240B29-F687-4f45-9708-019B960494DF}">
-                  <a14:hiddenLine xmlns:a14="http://schemas.microsoft.com/office/drawing/2010/main" xmlns="" w="9525">
+                  <a14:hiddenLine xmlns="" xmlns:a14="http://schemas.microsoft.com/office/drawing/2010/main" w="9525">
                     <a:solidFill>
                       <a:srgbClr val="000000"/>
                     </a:solidFill>
@@ -11016,7 +11016,7 @@
               </a:ln>
               <a:extLst>
                 <a:ext uri="{91240B29-F687-4f45-9708-019B960494DF}">
-                  <a14:hiddenLine xmlns:a14="http://schemas.microsoft.com/office/drawing/2010/main" xmlns="" w="9525">
+                  <a14:hiddenLine xmlns="" xmlns:a14="http://schemas.microsoft.com/office/drawing/2010/main" w="9525">
                     <a:solidFill>
                       <a:srgbClr val="000000"/>
                     </a:solidFill>
@@ -11078,7 +11078,7 @@
               </a:ln>
               <a:extLst>
                 <a:ext uri="{91240B29-F687-4f45-9708-019B960494DF}">
-                  <a14:hiddenLine xmlns:a14="http://schemas.microsoft.com/office/drawing/2010/main" xmlns="" w="9525">
+                  <a14:hiddenLine xmlns="" xmlns:a14="http://schemas.microsoft.com/office/drawing/2010/main" w="9525">
                     <a:solidFill>
                       <a:srgbClr val="000000"/>
                     </a:solidFill>
@@ -11168,7 +11168,7 @@
               </a:ln>
               <a:extLst>
                 <a:ext uri="{91240B29-F687-4f45-9708-019B960494DF}">
-                  <a14:hiddenLine xmlns:a14="http://schemas.microsoft.com/office/drawing/2010/main" xmlns="" w="9525">
+                  <a14:hiddenLine xmlns="" xmlns:a14="http://schemas.microsoft.com/office/drawing/2010/main" w="9525">
                     <a:solidFill>
                       <a:srgbClr val="000000"/>
                     </a:solidFill>
@@ -11233,7 +11233,7 @@
               </a:ln>
               <a:extLst>
                 <a:ext uri="{91240B29-F687-4f45-9708-019B960494DF}">
-                  <a14:hiddenLine xmlns:a14="http://schemas.microsoft.com/office/drawing/2010/main" xmlns="" w="9525">
+                  <a14:hiddenLine xmlns="" xmlns:a14="http://schemas.microsoft.com/office/drawing/2010/main" w="9525">
                     <a:solidFill>
                       <a:srgbClr val="000000"/>
                     </a:solidFill>
@@ -11295,7 +11295,7 @@
               </a:ln>
               <a:extLst>
                 <a:ext uri="{91240B29-F687-4f45-9708-019B960494DF}">
-                  <a14:hiddenLine xmlns:a14="http://schemas.microsoft.com/office/drawing/2010/main" xmlns="" w="9525">
+                  <a14:hiddenLine xmlns="" xmlns:a14="http://schemas.microsoft.com/office/drawing/2010/main" w="9525">
                     <a:solidFill>
                       <a:srgbClr val="000000"/>
                     </a:solidFill>
@@ -11385,7 +11385,7 @@
               </a:ln>
               <a:extLst>
                 <a:ext uri="{91240B29-F687-4f45-9708-019B960494DF}">
-                  <a14:hiddenLine xmlns:a14="http://schemas.microsoft.com/office/drawing/2010/main" xmlns="" w="9525">
+                  <a14:hiddenLine xmlns="" xmlns:a14="http://schemas.microsoft.com/office/drawing/2010/main" w="9525">
                     <a:solidFill>
                       <a:srgbClr val="000000"/>
                     </a:solidFill>
@@ -11475,7 +11475,7 @@
               </a:ln>
               <a:extLst>
                 <a:ext uri="{91240B29-F687-4f45-9708-019B960494DF}">
-                  <a14:hiddenLine xmlns:a14="http://schemas.microsoft.com/office/drawing/2010/main" xmlns="" w="9525">
+                  <a14:hiddenLine xmlns="" xmlns:a14="http://schemas.microsoft.com/office/drawing/2010/main" w="9525">
                     <a:solidFill>
                       <a:srgbClr val="000000"/>
                     </a:solidFill>
@@ -11540,7 +11540,7 @@
               </a:ln>
               <a:extLst>
                 <a:ext uri="{91240B29-F687-4f45-9708-019B960494DF}">
-                  <a14:hiddenLine xmlns:a14="http://schemas.microsoft.com/office/drawing/2010/main" xmlns="" w="9525">
+                  <a14:hiddenLine xmlns="" xmlns:a14="http://schemas.microsoft.com/office/drawing/2010/main" w="9525">
                     <a:solidFill>
                       <a:srgbClr val="000000"/>
                     </a:solidFill>
@@ -11660,7 +11660,7 @@
               </a:ln>
               <a:extLst>
                 <a:ext uri="{91240B29-F687-4f45-9708-019B960494DF}">
-                  <a14:hiddenLine xmlns:a14="http://schemas.microsoft.com/office/drawing/2010/main" xmlns="" w="9525">
+                  <a14:hiddenLine xmlns="" xmlns:a14="http://schemas.microsoft.com/office/drawing/2010/main" w="9525">
                     <a:solidFill>
                       <a:srgbClr val="000000"/>
                     </a:solidFill>
@@ -11741,7 +11741,7 @@
               </a:ln>
               <a:extLst>
                 <a:ext uri="{91240B29-F687-4f45-9708-019B960494DF}">
-                  <a14:hiddenLine xmlns:a14="http://schemas.microsoft.com/office/drawing/2010/main" xmlns="" w="9525">
+                  <a14:hiddenLine xmlns="" xmlns:a14="http://schemas.microsoft.com/office/drawing/2010/main" w="9525">
                     <a:solidFill>
                       <a:srgbClr val="000000"/>
                     </a:solidFill>
@@ -11856,7 +11856,7 @@
               </a:ln>
               <a:extLst>
                 <a:ext uri="{91240B29-F687-4f45-9708-019B960494DF}">
-                  <a14:hiddenLine xmlns:a14="http://schemas.microsoft.com/office/drawing/2010/main" xmlns="" w="9525">
+                  <a14:hiddenLine xmlns="" xmlns:a14="http://schemas.microsoft.com/office/drawing/2010/main" w="9525">
                     <a:solidFill>
                       <a:srgbClr val="000000"/>
                     </a:solidFill>
@@ -11946,7 +11946,7 @@
               </a:ln>
               <a:extLst>
                 <a:ext uri="{91240B29-F687-4f45-9708-019B960494DF}">
-                  <a14:hiddenLine xmlns:a14="http://schemas.microsoft.com/office/drawing/2010/main" xmlns="" w="9525">
+                  <a14:hiddenLine xmlns="" xmlns:a14="http://schemas.microsoft.com/office/drawing/2010/main" w="9525">
                     <a:solidFill>
                       <a:srgbClr val="000000"/>
                     </a:solidFill>
@@ -12011,7 +12011,7 @@
               </a:ln>
               <a:extLst>
                 <a:ext uri="{91240B29-F687-4f45-9708-019B960494DF}">
-                  <a14:hiddenLine xmlns:a14="http://schemas.microsoft.com/office/drawing/2010/main" xmlns="" w="9525">
+                  <a14:hiddenLine xmlns="" xmlns:a14="http://schemas.microsoft.com/office/drawing/2010/main" w="9525">
                     <a:solidFill>
                       <a:srgbClr val="000000"/>
                     </a:solidFill>
@@ -12101,7 +12101,7 @@
               </a:ln>
               <a:extLst>
                 <a:ext uri="{91240B29-F687-4f45-9708-019B960494DF}">
-                  <a14:hiddenLine xmlns:a14="http://schemas.microsoft.com/office/drawing/2010/main" xmlns="" w="9525">
+                  <a14:hiddenLine xmlns="" xmlns:a14="http://schemas.microsoft.com/office/drawing/2010/main" w="9525">
                     <a:solidFill>
                       <a:srgbClr val="000000"/>
                     </a:solidFill>
@@ -12169,7 +12169,7 @@
               </a:ln>
               <a:extLst>
                 <a:ext uri="{91240B29-F687-4f45-9708-019B960494DF}">
-                  <a14:hiddenLine xmlns:a14="http://schemas.microsoft.com/office/drawing/2010/main" xmlns="" w="9525">
+                  <a14:hiddenLine xmlns="" xmlns:a14="http://schemas.microsoft.com/office/drawing/2010/main" w="9525">
                     <a:solidFill>
                       <a:srgbClr val="000000"/>
                     </a:solidFill>
@@ -12259,7 +12259,7 @@
               </a:ln>
               <a:extLst>
                 <a:ext uri="{91240B29-F687-4f45-9708-019B960494DF}">
-                  <a14:hiddenLine xmlns:a14="http://schemas.microsoft.com/office/drawing/2010/main" xmlns="" w="9525">
+                  <a14:hiddenLine xmlns="" xmlns:a14="http://schemas.microsoft.com/office/drawing/2010/main" w="9525">
                     <a:solidFill>
                       <a:srgbClr val="000000"/>
                     </a:solidFill>
@@ -12327,7 +12327,7 @@
               </a:ln>
               <a:extLst>
                 <a:ext uri="{91240B29-F687-4f45-9708-019B960494DF}">
-                  <a14:hiddenLine xmlns:a14="http://schemas.microsoft.com/office/drawing/2010/main" xmlns="" w="9525">
+                  <a14:hiddenLine xmlns="" xmlns:a14="http://schemas.microsoft.com/office/drawing/2010/main" w="9525">
                     <a:solidFill>
                       <a:srgbClr val="000000"/>
                     </a:solidFill>
@@ -12417,7 +12417,7 @@
               </a:ln>
               <a:extLst>
                 <a:ext uri="{91240B29-F687-4f45-9708-019B960494DF}">
-                  <a14:hiddenLine xmlns:a14="http://schemas.microsoft.com/office/drawing/2010/main" xmlns="" w="9525">
+                  <a14:hiddenLine xmlns="" xmlns:a14="http://schemas.microsoft.com/office/drawing/2010/main" w="9525">
                     <a:solidFill>
                       <a:srgbClr val="000000"/>
                     </a:solidFill>
@@ -12451,7 +12451,7 @@
               </a:ln>
               <a:extLst>
                 <a:ext uri="{91240B29-F687-4f45-9708-019B960494DF}">
-                  <a14:hiddenLine xmlns:a14="http://schemas.microsoft.com/office/drawing/2010/main" xmlns="" w="9525">
+                  <a14:hiddenLine xmlns="" xmlns:a14="http://schemas.microsoft.com/office/drawing/2010/main" w="9525">
                     <a:solidFill>
                       <a:srgbClr val="000000"/>
                     </a:solidFill>
@@ -12591,7 +12591,7 @@
           <a:p>
             <a:fld id="{59173DD1-A275-4445-AB1E-9DFF752BE39B}" type="datetime1">
               <a:rPr lang="en-US" smtClean="0"/>
-              <a:t>8/18/26</a:t>
+              <a:t>8/25/26</a:t>
             </a:fld>
             <a:endParaRPr lang="en-US"/>
           </a:p>
@@ -14107,8 +14107,8 @@
           </a:p>
         </p:txBody>
       </p:sp>
-      <mc:AlternateContent xmlns:mc="http://schemas.openxmlformats.org/markup-compatibility/2006">
-        <mc:Choice xmlns:a14="http://schemas.microsoft.com/office/drawing/2010/main" Requires="a14">
+      <mc:AlternateContent xmlns:mc="http://schemas.openxmlformats.org/markup-compatibility/2006" xmlns:a14="http://schemas.microsoft.com/office/drawing/2010/main">
+        <mc:Choice Requires="a14">
           <p:sp>
             <p:nvSpPr>
               <p:cNvPr id="307203" name="Rectangle 3">
@@ -14301,7 +14301,7 @@
             </p:txBody>
           </p:sp>
         </mc:Choice>
-        <mc:Fallback>
+        <mc:Fallback xmlns="">
           <p:sp>
             <p:nvSpPr>
               <p:cNvPr id="307203" name="Rectangle 3">
@@ -14317,7 +14317,7 @@
               <p:nvPr>
                 <p:ph idx="1"/>
                 <p:custDataLst>
-                  <p:tags r:id="rId2"/>
+                  <p:tags r:id="rId4"/>
                 </p:custDataLst>
               </p:nvPr>
             </p:nvSpPr>
@@ -14327,7 +14327,7 @@
                 <a:ext cx="9905998" cy="5499979"/>
               </a:xfrm>
               <a:blipFill>
-                <a:blip r:embed="rId4"/>
+                <a:blip r:embed="rId5"/>
                 <a:stretch>
                   <a:fillRect l="-1280" t="-3002"/>
                 </a:stretch>

</xml_diff>